<commit_message>
refactor: improve readability with alignment, comments, and minor cleanup
</commit_message>
<xml_diff>
--- a/Presentation for protection.pptx
+++ b/Presentation for protection.pptx
@@ -222,7 +222,7 @@
           <a:effectLst/>
           <a:extLst>
             <a:ext uri="{91240B29-F687-4f45-9708-019B960494DF}">
-              <a14:hiddenLine xmlns="" xmlns:a14="http://schemas.microsoft.com/office/drawing/2010/main" w="9525">
+              <a14:hiddenLine xmlns:a14="http://schemas.microsoft.com/office/drawing/2010/main" xmlns="" w="9525">
                 <a:solidFill>
                   <a:srgbClr val="000000"/>
                 </a:solidFill>
@@ -421,7 +421,7 @@
           <a:p>
             <a:fld id="{B35CB3CD-B0A9-9B48-8D92-5C9BA64E899F}" type="datetimeFigureOut">
               <a:rPr lang="en-US" smtClean="0"/>
-              <a:t>3/12/26</a:t>
+              <a:t>3/15/26</a:t>
             </a:fld>
             <a:endParaRPr lang="en-US"/>
           </a:p>
@@ -739,7 +739,7 @@
           <a:p>
             <a:fld id="{B35CB3CD-B0A9-9B48-8D92-5C9BA64E899F}" type="datetimeFigureOut">
               <a:rPr lang="en-US" smtClean="0"/>
-              <a:t>3/12/26</a:t>
+              <a:t>3/15/26</a:t>
             </a:fld>
             <a:endParaRPr lang="en-US"/>
           </a:p>
@@ -1234,7 +1234,7 @@
           <a:p>
             <a:fld id="{B35CB3CD-B0A9-9B48-8D92-5C9BA64E899F}" type="datetimeFigureOut">
               <a:rPr lang="en-US" smtClean="0"/>
-              <a:t>3/12/26</a:t>
+              <a:t>3/15/26</a:t>
             </a:fld>
             <a:endParaRPr lang="en-US"/>
           </a:p>
@@ -1610,7 +1610,7 @@
           <a:p>
             <a:fld id="{B35CB3CD-B0A9-9B48-8D92-5C9BA64E899F}" type="datetimeFigureOut">
               <a:rPr lang="en-US" smtClean="0"/>
-              <a:t>3/12/26</a:t>
+              <a:t>3/15/26</a:t>
             </a:fld>
             <a:endParaRPr lang="en-US"/>
           </a:p>
@@ -1765,7 +1765,7 @@
           <a:ln/>
           <a:extLst>
             <a:ext uri="{91240B29-F687-4f45-9708-019B960494DF}">
-              <a14:hiddenLine xmlns="" xmlns:a14="http://schemas.microsoft.com/office/drawing/2010/main" w="9525">
+              <a14:hiddenLine xmlns:a14="http://schemas.microsoft.com/office/drawing/2010/main" xmlns="" w="9525">
                 <a:solidFill>
                   <a:srgbClr val="000000"/>
                 </a:solidFill>
@@ -1890,7 +1890,7 @@
           <a:p>
             <a:fld id="{B35CB3CD-B0A9-9B48-8D92-5C9BA64E899F}" type="datetimeFigureOut">
               <a:rPr lang="en-US" smtClean="0"/>
-              <a:t>3/12/26</a:t>
+              <a:t>3/15/26</a:t>
             </a:fld>
             <a:endParaRPr lang="en-US"/>
           </a:p>
@@ -2047,7 +2047,7 @@
           <a:ln/>
           <a:extLst>
             <a:ext uri="{91240B29-F687-4f45-9708-019B960494DF}">
-              <a14:hiddenLine xmlns="" xmlns:a14="http://schemas.microsoft.com/office/drawing/2010/main" w="9525">
+              <a14:hiddenLine xmlns:a14="http://schemas.microsoft.com/office/drawing/2010/main" xmlns="" w="9525">
                 <a:solidFill>
                   <a:srgbClr val="000000"/>
                 </a:solidFill>
@@ -2182,7 +2182,7 @@
           <a:p>
             <a:fld id="{B35CB3CD-B0A9-9B48-8D92-5C9BA64E899F}" type="datetimeFigureOut">
               <a:rPr lang="en-US" smtClean="0"/>
-              <a:t>3/12/26</a:t>
+              <a:t>3/15/26</a:t>
             </a:fld>
             <a:endParaRPr lang="en-US"/>
           </a:p>
@@ -2337,7 +2337,7 @@
           <a:ln/>
           <a:extLst>
             <a:ext uri="{91240B29-F687-4f45-9708-019B960494DF}">
-              <a14:hiddenLine xmlns="" xmlns:a14="http://schemas.microsoft.com/office/drawing/2010/main" w="9525">
+              <a14:hiddenLine xmlns:a14="http://schemas.microsoft.com/office/drawing/2010/main" xmlns="" w="9525">
                 <a:solidFill>
                   <a:srgbClr val="000000"/>
                 </a:solidFill>
@@ -2472,7 +2472,7 @@
           <a:p>
             <a:fld id="{B35CB3CD-B0A9-9B48-8D92-5C9BA64E899F}" type="datetimeFigureOut">
               <a:rPr lang="en-US" smtClean="0"/>
-              <a:t>3/12/26</a:t>
+              <a:t>3/15/26</a:t>
             </a:fld>
             <a:endParaRPr lang="en-US"/>
           </a:p>
@@ -2822,7 +2822,7 @@
           <a:p>
             <a:fld id="{B35CB3CD-B0A9-9B48-8D92-5C9BA64E899F}" type="datetimeFigureOut">
               <a:rPr lang="en-US" smtClean="0"/>
-              <a:t>3/12/26</a:t>
+              <a:t>3/15/26</a:t>
             </a:fld>
             <a:endParaRPr lang="en-US"/>
           </a:p>
@@ -2977,7 +2977,7 @@
           <a:ln/>
           <a:extLst>
             <a:ext uri="{91240B29-F687-4f45-9708-019B960494DF}">
-              <a14:hiddenLine xmlns="" xmlns:a14="http://schemas.microsoft.com/office/drawing/2010/main" w="9525">
+              <a14:hiddenLine xmlns:a14="http://schemas.microsoft.com/office/drawing/2010/main" xmlns="" w="9525">
                 <a:solidFill>
                   <a:srgbClr val="000000"/>
                 </a:solidFill>
@@ -3168,7 +3168,7 @@
           <a:p>
             <a:fld id="{B35CB3CD-B0A9-9B48-8D92-5C9BA64E899F}" type="datetimeFigureOut">
               <a:rPr lang="en-US" smtClean="0"/>
-              <a:t>3/12/26</a:t>
+              <a:t>3/15/26</a:t>
             </a:fld>
             <a:endParaRPr lang="en-US"/>
           </a:p>
@@ -3323,7 +3323,7 @@
           <a:ln/>
           <a:extLst>
             <a:ext uri="{91240B29-F687-4f45-9708-019B960494DF}">
-              <a14:hiddenLine xmlns="" xmlns:a14="http://schemas.microsoft.com/office/drawing/2010/main" w="9525">
+              <a14:hiddenLine xmlns:a14="http://schemas.microsoft.com/office/drawing/2010/main" xmlns="" w="9525">
                 <a:solidFill>
                   <a:srgbClr val="000000"/>
                 </a:solidFill>
@@ -3652,7 +3652,7 @@
           <a:p>
             <a:fld id="{B35CB3CD-B0A9-9B48-8D92-5C9BA64E899F}" type="datetimeFigureOut">
               <a:rPr lang="en-US" smtClean="0"/>
-              <a:t>3/12/26</a:t>
+              <a:t>3/15/26</a:t>
             </a:fld>
             <a:endParaRPr lang="en-US"/>
           </a:p>
@@ -3807,7 +3807,7 @@
           <a:ln/>
           <a:extLst>
             <a:ext uri="{91240B29-F687-4f45-9708-019B960494DF}">
-              <a14:hiddenLine xmlns="" xmlns:a14="http://schemas.microsoft.com/office/drawing/2010/main" w="9525">
+              <a14:hiddenLine xmlns:a14="http://schemas.microsoft.com/office/drawing/2010/main" xmlns="" w="9525">
                 <a:solidFill>
                   <a:srgbClr val="000000"/>
                 </a:solidFill>
@@ -3880,7 +3880,7 @@
           <a:p>
             <a:fld id="{B35CB3CD-B0A9-9B48-8D92-5C9BA64E899F}" type="datetimeFigureOut">
               <a:rPr lang="en-US" smtClean="0"/>
-              <a:t>3/12/26</a:t>
+              <a:t>3/15/26</a:t>
             </a:fld>
             <a:endParaRPr lang="en-US"/>
           </a:p>
@@ -3975,7 +3975,7 @@
           <a:p>
             <a:fld id="{B35CB3CD-B0A9-9B48-8D92-5C9BA64E899F}" type="datetimeFigureOut">
               <a:rPr lang="en-US" smtClean="0"/>
-              <a:t>3/12/26</a:t>
+              <a:t>3/15/26</a:t>
             </a:fld>
             <a:endParaRPr lang="en-US"/>
           </a:p>
@@ -4243,7 +4243,7 @@
           <a:ln/>
           <a:extLst>
             <a:ext uri="{91240B29-F687-4f45-9708-019B960494DF}">
-              <a14:hiddenLine xmlns="" xmlns:a14="http://schemas.microsoft.com/office/drawing/2010/main" w="9525">
+              <a14:hiddenLine xmlns:a14="http://schemas.microsoft.com/office/drawing/2010/main" xmlns="" w="9525">
                 <a:solidFill>
                   <a:srgbClr val="000000"/>
                 </a:solidFill>
@@ -4449,7 +4449,7 @@
           <a:p>
             <a:fld id="{B35CB3CD-B0A9-9B48-8D92-5C9BA64E899F}" type="datetimeFigureOut">
               <a:rPr lang="en-US" smtClean="0"/>
-              <a:t>3/12/26</a:t>
+              <a:t>3/15/26</a:t>
             </a:fld>
             <a:endParaRPr lang="en-US"/>
           </a:p>
@@ -4762,7 +4762,7 @@
           <a:p>
             <a:fld id="{B35CB3CD-B0A9-9B48-8D92-5C9BA64E899F}" type="datetimeFigureOut">
               <a:rPr lang="en-US" smtClean="0"/>
-              <a:t>3/12/26</a:t>
+              <a:t>3/15/26</a:t>
             </a:fld>
             <a:endParaRPr lang="en-US"/>
           </a:p>
@@ -5032,7 +5032,7 @@
           <a:p>
             <a:fld id="{B35CB3CD-B0A9-9B48-8D92-5C9BA64E899F}" type="datetimeFigureOut">
               <a:rPr lang="en-US" smtClean="0"/>
-              <a:t>3/12/26</a:t>
+              <a:t>3/15/26</a:t>
             </a:fld>
             <a:endParaRPr lang="en-US"/>
           </a:p>
@@ -6075,7 +6075,7 @@
           <a:effectLst/>
           <a:extLst>
             <a:ext uri="{91240B29-F687-4f45-9708-019B960494DF}">
-              <a14:hiddenLine xmlns="" xmlns:a16="http://schemas.microsoft.com/office/drawing/2014/main" xmlns:p14="http://schemas.microsoft.com/office/powerpoint/2010/main" xmlns:a14="http://schemas.microsoft.com/office/drawing/2010/main" w="9525">
+              <a14:hiddenLine xmlns:a14="http://schemas.microsoft.com/office/drawing/2010/main" xmlns:p14="http://schemas.microsoft.com/office/powerpoint/2010/main" xmlns:a16="http://schemas.microsoft.com/office/drawing/2014/main" xmlns="" w="9525">
                 <a:solidFill>
                   <a:srgbClr val="000000"/>
                 </a:solidFill>
@@ -6510,7 +6510,20 @@
               <a:schemeClr val="accent1"/>
             </a:solidFill>
           </a:ln>
-          <a:effectLst/>
+          <a:effectLst>
+            <a:glow rad="980170">
+              <a:schemeClr val="accent1">
+                <a:alpha val="86626"/>
+              </a:schemeClr>
+            </a:glow>
+            <a:softEdge rad="0"/>
+          </a:effectLst>
+          <a:scene3d>
+            <a:camera prst="orthographicFront">
+              <a:rot lat="0" lon="21599983" rev="0"/>
+            </a:camera>
+            <a:lightRig rig="threePt" dir="t"/>
+          </a:scene3d>
         </p:spPr>
       </p:pic>
     </p:spTree>

</xml_diff>